<commit_message>
Embed IBM Plex Mono and Noto Serif KR fonts in donggu_ai_club_0826.pptx
</commit_message>
<xml_diff>
--- a/files/donggu_ai_club_0826.pptx
+++ b/files/donggu_ai_club_0826.pptx
@@ -1,6 +1,6 @@
 
 <file path=ppt/presentation.xml><?xml version="1.0" encoding="utf-8"?>
-<p:presentation xmlns:a="http://schemas.openxmlformats.org/drawingml/2006/main" xmlns:r="http://schemas.openxmlformats.org/officeDocument/2006/relationships" xmlns:p="http://schemas.openxmlformats.org/presentationml/2006/main" saveSubsetFonts="1" autoCompressPictures="0">
+<p:presentation xmlns:a="http://schemas.openxmlformats.org/drawingml/2006/main" xmlns:r="http://schemas.openxmlformats.org/officeDocument/2006/relationships" xmlns:p="http://schemas.openxmlformats.org/presentationml/2006/main" embedTrueTypeFonts="1" saveSubsetFonts="1" autoCompressPictures="0">
   <p:sldMasterIdLst>
     <p:sldMasterId id="2147483648" r:id="rId1"/>
   </p:sldMasterIdLst>
@@ -21,6 +21,18 @@
   </p:sldIdLst>
   <p:sldSz cx="18288000" cy="10287000"/>
   <p:notesSz cx="10287000" cy="18288000"/>
+  <p:embeddedFontLst>
+    <p:embeddedFont>
+      <p:font typeface="IBM Plex Mono"/>
+      <p:regular r:id="rIdFont1"/>
+      <p:bold r:id="rIdFont2"/>
+    </p:embeddedFont>
+    <p:embeddedFont>
+      <p:font typeface="Noto Serif KR"/>
+      <p:regular r:id="rIdFont3"/>
+      <p:bold r:id="rIdFont4"/>
+    </p:embeddedFont>
+  </p:embeddedFontLst>
   <p:defaultTextStyle>
     <a:lvl1pPr marL="0" algn="l" defTabSz="914400" rtl="0" eaLnBrk="1" latinLnBrk="0" hangingPunct="1">
       <a:defRPr sz="1800" kern="1200">

</xml_diff>